<commit_message>
upload updated data and sources
</commit_message>
<xml_diff>
--- a/CSV+Code Files/RISE Expo Material/RISE_2026_MLB_Draft_Poster.pptx
+++ b/CSV+Code Files/RISE Expo Material/RISE_2026_MLB_Draft_Poster.pptx
@@ -134,13 +134,13 @@
               </a:defRPr>
             </a:pPr>
             <a:r>
-              <a:rPr lang="en-US" sz="1800" b="0" i="0" u="none" strike="noStrike">
+              <a:rPr lang="en-US" sz="1800" b="0" i="0" u="none" strike="noStrike" dirty="0">
                 <a:solidFill>
                   <a:srgbClr val="0F2340"/>
                 </a:solidFill>
                 <a:latin typeface="Calibri"/>
               </a:rPr>
-              <a:t>Draft Classifier — Top 8 Features (Gain)</a:t>
+              <a:t>Draft Classifier — Top 10 Features (Gain)</a:t>
             </a:r>
           </a:p>
         </c:rich>
@@ -157,17 +157,6 @@
         <c:ser>
           <c:idx val="0"/>
           <c:order val="0"/>
-          <c:tx>
-            <c:strRef>
-              <c:f>Sheet1!$B$1</c:f>
-              <c:strCache>
-                <c:ptCount val="1"/>
-                <c:pt idx="0">
-                  <c:v>Gain</c:v>
-                </c:pt>
-              </c:strCache>
-            </c:strRef>
-          </c:tx>
           <c:spPr>
             <a:solidFill>
               <a:srgbClr val="0F2340"/>
@@ -176,12 +165,44 @@
           </c:spPr>
           <c:invertIfNegative val="0"/>
           <c:dPt>
+            <c:idx val="0"/>
+            <c:invertIfNegative val="0"/>
+            <c:bubble3D val="0"/>
+            <c:spPr>
+              <a:solidFill>
+                <a:srgbClr val="C8102E"/>
+              </a:solidFill>
+              <a:effectLst/>
+            </c:spPr>
+            <c:extLst>
+              <c:ext xmlns:c16="http://schemas.microsoft.com/office/drawing/2014/chart" uri="{C3380CC4-5D6E-409C-BE32-E72D297353CC}">
+                <c16:uniqueId val="{00000003-FC93-CA46-A7BD-45E069A6D829}"/>
+              </c:ext>
+            </c:extLst>
+          </c:dPt>
+          <c:dPt>
+            <c:idx val="6"/>
+            <c:invertIfNegative val="0"/>
+            <c:bubble3D val="0"/>
+            <c:spPr>
+              <a:solidFill>
+                <a:srgbClr val="002060"/>
+              </a:solidFill>
+              <a:effectLst/>
+            </c:spPr>
+            <c:extLst>
+              <c:ext xmlns:c16="http://schemas.microsoft.com/office/drawing/2014/chart" uri="{C3380CC4-5D6E-409C-BE32-E72D297353CC}">
+                <c16:uniqueId val="{00000002-FC93-CA46-A7BD-45E069A6D829}"/>
+              </c:ext>
+            </c:extLst>
+          </c:dPt>
+          <c:dPt>
             <c:idx val="7"/>
             <c:invertIfNegative val="0"/>
             <c:bubble3D val="0"/>
             <c:spPr>
               <a:solidFill>
-                <a:srgbClr val="C8102E"/>
+                <a:srgbClr val="0F2240"/>
               </a:solidFill>
               <a:effectLst/>
             </c:spPr>
@@ -193,8 +214,267 @@
           </c:dPt>
           <c:dLbls>
             <c:dLbl>
+              <c:idx val="0"/>
+              <c:numFmt formatCode="#,##0.0" sourceLinked="0"/>
+              <c:spPr>
+                <a:noFill/>
+                <a:ln>
+                  <a:noFill/>
+                </a:ln>
+                <a:effectLst/>
+              </c:spPr>
+              <c:txPr>
+                <a:bodyPr/>
+                <a:lstStyle/>
+                <a:p>
+                  <a:pPr>
+                    <a:defRPr sz="1500" b="0" i="0" u="none" strike="noStrike">
+                      <a:solidFill>
+                        <a:srgbClr val="1A1A2E"/>
+                      </a:solidFill>
+                      <a:latin typeface="Arial"/>
+                    </a:defRPr>
+                  </a:pPr>
+                  <a:endParaRPr lang="en-US"/>
+                </a:p>
+              </c:txPr>
+              <c:showLegendKey val="0"/>
+              <c:showVal val="1"/>
+              <c:showCatName val="0"/>
+              <c:showSerName val="0"/>
+              <c:showPercent val="0"/>
+              <c:showBubbleSize val="0"/>
+              <c:extLst>
+                <c:ext xmlns:c16="http://schemas.microsoft.com/office/drawing/2014/chart" uri="{C3380CC4-5D6E-409C-BE32-E72D297353CC}">
+                  <c16:uniqueId val="{00000003-FC93-CA46-A7BD-45E069A6D829}"/>
+                </c:ext>
+              </c:extLst>
+            </c:dLbl>
+            <c:dLbl>
+              <c:idx val="1"/>
+              <c:numFmt formatCode="#,##0.0" sourceLinked="0"/>
+              <c:spPr>
+                <a:noFill/>
+                <a:ln>
+                  <a:noFill/>
+                </a:ln>
+                <a:effectLst/>
+              </c:spPr>
+              <c:txPr>
+                <a:bodyPr/>
+                <a:lstStyle/>
+                <a:p>
+                  <a:pPr>
+                    <a:defRPr sz="1500" b="0" i="0" u="none" strike="noStrike">
+                      <a:solidFill>
+                        <a:srgbClr val="1A1A2E"/>
+                      </a:solidFill>
+                      <a:latin typeface="Arial"/>
+                    </a:defRPr>
+                  </a:pPr>
+                  <a:endParaRPr lang="en-US"/>
+                </a:p>
+              </c:txPr>
+              <c:showLegendKey val="0"/>
+              <c:showVal val="1"/>
+              <c:showCatName val="0"/>
+              <c:showSerName val="0"/>
+              <c:showPercent val="0"/>
+              <c:showBubbleSize val="0"/>
+              <c:extLst>
+                <c:ext xmlns:c16="http://schemas.microsoft.com/office/drawing/2014/chart" uri="{C3380CC4-5D6E-409C-BE32-E72D297353CC}">
+                  <c16:uniqueId val="{0000000A-FC93-CA46-A7BD-45E069A6D829}"/>
+                </c:ext>
+              </c:extLst>
+            </c:dLbl>
+            <c:dLbl>
+              <c:idx val="2"/>
+              <c:numFmt formatCode="#,##0.0" sourceLinked="0"/>
+              <c:spPr>
+                <a:noFill/>
+                <a:ln>
+                  <a:noFill/>
+                </a:ln>
+                <a:effectLst/>
+              </c:spPr>
+              <c:txPr>
+                <a:bodyPr/>
+                <a:lstStyle/>
+                <a:p>
+                  <a:pPr>
+                    <a:defRPr sz="1500" b="0" i="0" u="none" strike="noStrike">
+                      <a:solidFill>
+                        <a:srgbClr val="1A1A2E"/>
+                      </a:solidFill>
+                      <a:latin typeface="Arial"/>
+                    </a:defRPr>
+                  </a:pPr>
+                  <a:endParaRPr lang="en-US"/>
+                </a:p>
+              </c:txPr>
+              <c:showLegendKey val="0"/>
+              <c:showVal val="1"/>
+              <c:showCatName val="0"/>
+              <c:showSerName val="0"/>
+              <c:showPercent val="0"/>
+              <c:showBubbleSize val="0"/>
+              <c:extLst>
+                <c:ext xmlns:c16="http://schemas.microsoft.com/office/drawing/2014/chart" uri="{C3380CC4-5D6E-409C-BE32-E72D297353CC}">
+                  <c16:uniqueId val="{00000009-FC93-CA46-A7BD-45E069A6D829}"/>
+                </c:ext>
+              </c:extLst>
+            </c:dLbl>
+            <c:dLbl>
+              <c:idx val="3"/>
+              <c:numFmt formatCode="#,##0.0" sourceLinked="0"/>
+              <c:spPr>
+                <a:noFill/>
+                <a:ln>
+                  <a:noFill/>
+                </a:ln>
+                <a:effectLst/>
+              </c:spPr>
+              <c:txPr>
+                <a:bodyPr/>
+                <a:lstStyle/>
+                <a:p>
+                  <a:pPr>
+                    <a:defRPr sz="1500" b="0" i="0" u="none" strike="noStrike">
+                      <a:solidFill>
+                        <a:srgbClr val="1A1A2E"/>
+                      </a:solidFill>
+                      <a:latin typeface="Arial"/>
+                    </a:defRPr>
+                  </a:pPr>
+                  <a:endParaRPr lang="en-US"/>
+                </a:p>
+              </c:txPr>
+              <c:showLegendKey val="0"/>
+              <c:showVal val="1"/>
+              <c:showCatName val="0"/>
+              <c:showSerName val="0"/>
+              <c:showPercent val="0"/>
+              <c:showBubbleSize val="0"/>
+              <c:extLst>
+                <c:ext xmlns:c16="http://schemas.microsoft.com/office/drawing/2014/chart" uri="{C3380CC4-5D6E-409C-BE32-E72D297353CC}">
+                  <c16:uniqueId val="{00000008-FC93-CA46-A7BD-45E069A6D829}"/>
+                </c:ext>
+              </c:extLst>
+            </c:dLbl>
+            <c:dLbl>
+              <c:idx val="4"/>
+              <c:numFmt formatCode="#,##0.0" sourceLinked="0"/>
+              <c:spPr>
+                <a:noFill/>
+                <a:ln>
+                  <a:noFill/>
+                </a:ln>
+                <a:effectLst/>
+              </c:spPr>
+              <c:txPr>
+                <a:bodyPr/>
+                <a:lstStyle/>
+                <a:p>
+                  <a:pPr>
+                    <a:defRPr sz="1500" b="0" i="0" u="none" strike="noStrike">
+                      <a:solidFill>
+                        <a:srgbClr val="1A1A2E"/>
+                      </a:solidFill>
+                      <a:latin typeface="Arial"/>
+                    </a:defRPr>
+                  </a:pPr>
+                  <a:endParaRPr lang="en-US"/>
+                </a:p>
+              </c:txPr>
+              <c:showLegendKey val="0"/>
+              <c:showVal val="1"/>
+              <c:showCatName val="0"/>
+              <c:showSerName val="0"/>
+              <c:showPercent val="0"/>
+              <c:showBubbleSize val="0"/>
+              <c:extLst>
+                <c:ext xmlns:c16="http://schemas.microsoft.com/office/drawing/2014/chart" uri="{C3380CC4-5D6E-409C-BE32-E72D297353CC}">
+                  <c16:uniqueId val="{00000007-FC93-CA46-A7BD-45E069A6D829}"/>
+                </c:ext>
+              </c:extLst>
+            </c:dLbl>
+            <c:dLbl>
+              <c:idx val="5"/>
+              <c:numFmt formatCode="#,##0.0" sourceLinked="0"/>
+              <c:spPr>
+                <a:noFill/>
+                <a:ln>
+                  <a:noFill/>
+                </a:ln>
+                <a:effectLst/>
+              </c:spPr>
+              <c:txPr>
+                <a:bodyPr/>
+                <a:lstStyle/>
+                <a:p>
+                  <a:pPr>
+                    <a:defRPr sz="1500" b="0" i="0" u="none" strike="noStrike">
+                      <a:solidFill>
+                        <a:srgbClr val="1A1A2E"/>
+                      </a:solidFill>
+                      <a:latin typeface="Arial"/>
+                    </a:defRPr>
+                  </a:pPr>
+                  <a:endParaRPr lang="en-US"/>
+                </a:p>
+              </c:txPr>
+              <c:showLegendKey val="0"/>
+              <c:showVal val="1"/>
+              <c:showCatName val="0"/>
+              <c:showSerName val="0"/>
+              <c:showPercent val="0"/>
+              <c:showBubbleSize val="0"/>
+              <c:extLst>
+                <c:ext xmlns:c16="http://schemas.microsoft.com/office/drawing/2014/chart" uri="{C3380CC4-5D6E-409C-BE32-E72D297353CC}">
+                  <c16:uniqueId val="{00000006-FC93-CA46-A7BD-45E069A6D829}"/>
+                </c:ext>
+              </c:extLst>
+            </c:dLbl>
+            <c:dLbl>
+              <c:idx val="6"/>
+              <c:numFmt formatCode="#,##0.0" sourceLinked="0"/>
+              <c:spPr>
+                <a:noFill/>
+                <a:ln>
+                  <a:noFill/>
+                </a:ln>
+                <a:effectLst/>
+              </c:spPr>
+              <c:txPr>
+                <a:bodyPr/>
+                <a:lstStyle/>
+                <a:p>
+                  <a:pPr>
+                    <a:defRPr sz="1500" b="0" i="0" u="none" strike="noStrike">
+                      <a:solidFill>
+                        <a:srgbClr val="1A1A2E"/>
+                      </a:solidFill>
+                      <a:latin typeface="Arial"/>
+                    </a:defRPr>
+                  </a:pPr>
+                  <a:endParaRPr lang="en-US"/>
+                </a:p>
+              </c:txPr>
+              <c:showLegendKey val="0"/>
+              <c:showVal val="1"/>
+              <c:showCatName val="0"/>
+              <c:showSerName val="0"/>
+              <c:showPercent val="0"/>
+              <c:showBubbleSize val="0"/>
+              <c:extLst>
+                <c:ext xmlns:c16="http://schemas.microsoft.com/office/drawing/2014/chart" uri="{C3380CC4-5D6E-409C-BE32-E72D297353CC}">
+                  <c16:uniqueId val="{00000002-FC93-CA46-A7BD-45E069A6D829}"/>
+                </c:ext>
+              </c:extLst>
+            </c:dLbl>
+            <c:dLbl>
               <c:idx val="7"/>
-              <c:numFmt formatCode="#,##0" sourceLinked="0"/>
+              <c:numFmt formatCode="#,##0.0" sourceLinked="0"/>
               <c:spPr>
                 <a:noFill/>
                 <a:ln>
@@ -228,6 +508,80 @@
               <c:extLst>
                 <c:ext xmlns:c16="http://schemas.microsoft.com/office/drawing/2014/chart" uri="{C3380CC4-5D6E-409C-BE32-E72D297353CC}">
                   <c16:uniqueId val="{00000001-1EC5-4081-9945-D195D4F31550}"/>
+                </c:ext>
+              </c:extLst>
+            </c:dLbl>
+            <c:dLbl>
+              <c:idx val="8"/>
+              <c:numFmt formatCode="#,##0.0" sourceLinked="0"/>
+              <c:spPr>
+                <a:noFill/>
+                <a:ln>
+                  <a:noFill/>
+                </a:ln>
+                <a:effectLst/>
+              </c:spPr>
+              <c:txPr>
+                <a:bodyPr/>
+                <a:lstStyle/>
+                <a:p>
+                  <a:pPr>
+                    <a:defRPr sz="1500" b="0" i="0" u="none" strike="noStrike">
+                      <a:solidFill>
+                        <a:srgbClr val="1A1A2E"/>
+                      </a:solidFill>
+                      <a:latin typeface="Arial"/>
+                    </a:defRPr>
+                  </a:pPr>
+                  <a:endParaRPr lang="en-US"/>
+                </a:p>
+              </c:txPr>
+              <c:showLegendKey val="0"/>
+              <c:showVal val="1"/>
+              <c:showCatName val="0"/>
+              <c:showSerName val="0"/>
+              <c:showPercent val="0"/>
+              <c:showBubbleSize val="0"/>
+              <c:extLst>
+                <c:ext xmlns:c16="http://schemas.microsoft.com/office/drawing/2014/chart" uri="{C3380CC4-5D6E-409C-BE32-E72D297353CC}">
+                  <c16:uniqueId val="{00000005-FC93-CA46-A7BD-45E069A6D829}"/>
+                </c:ext>
+              </c:extLst>
+            </c:dLbl>
+            <c:dLbl>
+              <c:idx val="9"/>
+              <c:numFmt formatCode="#,##0.0" sourceLinked="0"/>
+              <c:spPr>
+                <a:noFill/>
+                <a:ln>
+                  <a:noFill/>
+                </a:ln>
+                <a:effectLst/>
+              </c:spPr>
+              <c:txPr>
+                <a:bodyPr/>
+                <a:lstStyle/>
+                <a:p>
+                  <a:pPr>
+                    <a:defRPr sz="1500" b="0" i="0" u="none" strike="noStrike">
+                      <a:solidFill>
+                        <a:srgbClr val="1A1A2E"/>
+                      </a:solidFill>
+                      <a:latin typeface="Arial"/>
+                    </a:defRPr>
+                  </a:pPr>
+                  <a:endParaRPr lang="en-US"/>
+                </a:p>
+              </c:txPr>
+              <c:showLegendKey val="0"/>
+              <c:showVal val="1"/>
+              <c:showCatName val="0"/>
+              <c:showSerName val="0"/>
+              <c:showPercent val="0"/>
+              <c:showBubbleSize val="0"/>
+              <c:extLst>
+                <c:ext xmlns:c16="http://schemas.microsoft.com/office/drawing/2014/chart" uri="{C3380CC4-5D6E-409C-BE32-E72D297353CC}">
+                  <c16:uniqueId val="{00000004-FC93-CA46-A7BD-45E069A6D829}"/>
                 </c:ext>
               </c:extLst>
             </c:dLbl>
@@ -269,17 +623,17 @@
           </c:dLbls>
           <c:cat>
             <c:strRef>
-              <c:f>Sheet1!$A$2:$A$9</c:f>
+              <c:f>Sheet1!$A$2:$A$11</c:f>
               <c:strCache>
-                <c:ptCount val="8"/>
+                <c:ptCount val="10"/>
                 <c:pt idx="0">
-                  <c:v>Conf. RPI (team)</c:v>
+                  <c:v>Age</c:v>
                 </c:pt>
                 <c:pt idx="1">
-                  <c:v>Conf. Rank (team)</c:v>
+                  <c:v>RPI (team)</c:v>
                 </c:pt>
                 <c:pt idx="2">
-                  <c:v>R (bat)</c:v>
+                  <c:v>wRC (bat)</c:v>
                 </c:pt>
                 <c:pt idx="3">
                   <c:v>SLG (bat)</c:v>
@@ -288,46 +642,58 @@
                   <c:v>SO (pitch)</c:v>
                 </c:pt>
                 <c:pt idx="5">
+                  <c:v>SOS (team)</c:v>
+                </c:pt>
+                <c:pt idx="6">
+                  <c:v>R (bat)</c:v>
+                </c:pt>
+                <c:pt idx="7">
                   <c:v>H (bat)</c:v>
                 </c:pt>
-                <c:pt idx="6">
-                  <c:v>wRC (bat)</c:v>
+                <c:pt idx="8">
+                  <c:v>Conf. RPI (team)</c:v>
                 </c:pt>
-                <c:pt idx="7">
-                  <c:v>Age</c:v>
+                <c:pt idx="9">
+                  <c:v>OPS (bat)</c:v>
                 </c:pt>
               </c:strCache>
             </c:strRef>
           </c:cat>
           <c:val>
             <c:numRef>
-              <c:f>Sheet1!$B$2:$B$9</c:f>
+              <c:f>Sheet1!$B$2:$B$11</c:f>
               <c:numCache>
                 <c:formatCode>General</c:formatCode>
-                <c:ptCount val="8"/>
+                <c:ptCount val="10"/>
                 <c:pt idx="0">
-                  <c:v>5.9089999999999998</c:v>
+                  <c:v>18.5</c:v>
                 </c:pt>
                 <c:pt idx="1">
-                  <c:v>7.0670000000000002</c:v>
+                  <c:v>13.5</c:v>
                 </c:pt>
                 <c:pt idx="2">
-                  <c:v>7.2080000000000002</c:v>
+                  <c:v>9.6</c:v>
                 </c:pt>
                 <c:pt idx="3">
-                  <c:v>7.8339999999999996</c:v>
+                  <c:v>9.3000000000000007</c:v>
                 </c:pt>
                 <c:pt idx="4">
-                  <c:v>7.9640000000000004</c:v>
+                  <c:v>9.1</c:v>
                 </c:pt>
                 <c:pt idx="5">
-                  <c:v>8.77</c:v>
+                  <c:v>7.3</c:v>
                 </c:pt>
                 <c:pt idx="6">
-                  <c:v>10</c:v>
+                  <c:v>6</c:v>
                 </c:pt>
                 <c:pt idx="7">
-                  <c:v>20.834</c:v>
+                  <c:v>5.6</c:v>
+                </c:pt>
+                <c:pt idx="8">
+                  <c:v>5.0999999999999996</c:v>
+                </c:pt>
+                <c:pt idx="9">
+                  <c:v>4.9000000000000004</c:v>
                 </c:pt>
               </c:numCache>
             </c:numRef>
@@ -4660,7 +5026,7 @@
           <p:nvPr>
             <p:extLst>
               <p:ext uri="{D42A27DB-BD31-4B8C-83A1-F6EECF244321}">
-                <p14:modId xmlns:p14="http://schemas.microsoft.com/office/powerpoint/2010/main" val="1478088863"/>
+                <p14:modId xmlns:p14="http://schemas.microsoft.com/office/powerpoint/2010/main" val="3392910100"/>
               </p:ext>
             </p:extLst>
           </p:nvPr>

</xml_diff>